<commit_message>
aggiornati report e presentazioni con nuovi file e modifiche
</commit_message>
<xml_diff>
--- a/report/presentation.pptx
+++ b/report/presentation.pptx
@@ -2007,7 +2007,7 @@
   <p:cSld>
     <p:spTree>
       <p:nvGrpSpPr>
-        <p:cNvPr id="546" name="Shape 546"/>
+        <p:cNvPr id="550" name="Shape 550"/>
         <p:cNvGrpSpPr/>
         <p:nvPr/>
       </p:nvGrpSpPr>
@@ -2021,7 +2021,7 @@
       </p:grpSpPr>
       <p:sp>
         <p:nvSpPr>
-          <p:cNvPr id="547" name="Google Shape;547;p28:notes"/>
+          <p:cNvPr id="551" name="Google Shape;551;p28:notes"/>
           <p:cNvSpPr txBox="1"/>
           <p:nvPr>
             <p:ph idx="1" type="body"/>
@@ -2060,7 +2060,7 @@
       </p:sp>
       <p:sp>
         <p:nvSpPr>
-          <p:cNvPr id="548" name="Google Shape;548;p28:notes"/>
+          <p:cNvPr id="552" name="Google Shape;552;p28:notes"/>
           <p:cNvSpPr/>
           <p:nvPr>
             <p:ph idx="2" type="sldImg"/>
@@ -2106,7 +2106,7 @@
   <p:cSld>
     <p:spTree>
       <p:nvGrpSpPr>
-        <p:cNvPr id="569" name="Shape 569"/>
+        <p:cNvPr id="573" name="Shape 573"/>
         <p:cNvGrpSpPr/>
         <p:nvPr/>
       </p:nvGrpSpPr>
@@ -2120,7 +2120,7 @@
       </p:grpSpPr>
       <p:sp>
         <p:nvSpPr>
-          <p:cNvPr id="570" name="Google Shape;570;g3eaf2debc62_0_112:notes"/>
+          <p:cNvPr id="574" name="Google Shape;574;g3eaf2debc62_0_112:notes"/>
           <p:cNvSpPr txBox="1"/>
           <p:nvPr>
             <p:ph idx="1" type="body"/>
@@ -2159,7 +2159,7 @@
       </p:sp>
       <p:sp>
         <p:nvSpPr>
-          <p:cNvPr id="571" name="Google Shape;571;g3eaf2debc62_0_112:notes"/>
+          <p:cNvPr id="575" name="Google Shape;575;g3eaf2debc62_0_112:notes"/>
           <p:cNvSpPr/>
           <p:nvPr>
             <p:ph idx="2" type="sldImg"/>
@@ -2205,7 +2205,7 @@
   <p:cSld>
     <p:spTree>
       <p:nvGrpSpPr>
-        <p:cNvPr id="590" name="Shape 590"/>
+        <p:cNvPr id="594" name="Shape 594"/>
         <p:cNvGrpSpPr/>
         <p:nvPr/>
       </p:nvGrpSpPr>
@@ -2219,7 +2219,7 @@
       </p:grpSpPr>
       <p:sp>
         <p:nvSpPr>
-          <p:cNvPr id="591" name="Google Shape;591;p31:notes"/>
+          <p:cNvPr id="595" name="Google Shape;595;p31:notes"/>
           <p:cNvSpPr txBox="1"/>
           <p:nvPr>
             <p:ph idx="1" type="body"/>
@@ -2258,7 +2258,7 @@
       </p:sp>
       <p:sp>
         <p:nvSpPr>
-          <p:cNvPr id="592" name="Google Shape;592;p31:notes"/>
+          <p:cNvPr id="596" name="Google Shape;596;p31:notes"/>
           <p:cNvSpPr/>
           <p:nvPr>
             <p:ph idx="2" type="sldImg"/>
@@ -2304,7 +2304,7 @@
   <p:cSld>
     <p:spTree>
       <p:nvGrpSpPr>
-        <p:cNvPr id="611" name="Shape 611"/>
+        <p:cNvPr id="615" name="Shape 615"/>
         <p:cNvGrpSpPr/>
         <p:nvPr/>
       </p:nvGrpSpPr>
@@ -2318,7 +2318,7 @@
       </p:grpSpPr>
       <p:sp>
         <p:nvSpPr>
-          <p:cNvPr id="612" name="Google Shape;612;p32:notes"/>
+          <p:cNvPr id="616" name="Google Shape;616;p32:notes"/>
           <p:cNvSpPr txBox="1"/>
           <p:nvPr>
             <p:ph idx="1" type="body"/>
@@ -2357,7 +2357,7 @@
       </p:sp>
       <p:sp>
         <p:nvSpPr>
-          <p:cNvPr id="613" name="Google Shape;613;p32:notes"/>
+          <p:cNvPr id="617" name="Google Shape;617;p32:notes"/>
           <p:cNvSpPr/>
           <p:nvPr>
             <p:ph idx="2" type="sldImg"/>
@@ -2403,7 +2403,7 @@
   <p:cSld>
     <p:spTree>
       <p:nvGrpSpPr>
-        <p:cNvPr id="635" name="Shape 635"/>
+        <p:cNvPr id="639" name="Shape 639"/>
         <p:cNvGrpSpPr/>
         <p:nvPr/>
       </p:nvGrpSpPr>
@@ -2417,7 +2417,7 @@
       </p:grpSpPr>
       <p:sp>
         <p:nvSpPr>
-          <p:cNvPr id="636" name="Google Shape;636;g3dbefcdd987_0_0:notes"/>
+          <p:cNvPr id="640" name="Google Shape;640;g3dbefcdd987_0_0:notes"/>
           <p:cNvSpPr txBox="1"/>
           <p:nvPr>
             <p:ph idx="1" type="body"/>
@@ -2456,7 +2456,7 @@
       </p:sp>
       <p:sp>
         <p:nvSpPr>
-          <p:cNvPr id="637" name="Google Shape;637;g3dbefcdd987_0_0:notes"/>
+          <p:cNvPr id="641" name="Google Shape;641;g3dbefcdd987_0_0:notes"/>
           <p:cNvSpPr/>
           <p:nvPr>
             <p:ph idx="2" type="sldImg"/>
@@ -2502,7 +2502,7 @@
   <p:cSld>
     <p:spTree>
       <p:nvGrpSpPr>
-        <p:cNvPr id="660" name="Shape 660"/>
+        <p:cNvPr id="664" name="Shape 664"/>
         <p:cNvGrpSpPr/>
         <p:nvPr/>
       </p:nvGrpSpPr>
@@ -2516,7 +2516,7 @@
       </p:grpSpPr>
       <p:sp>
         <p:nvSpPr>
-          <p:cNvPr id="661" name="Google Shape;661;p33:notes"/>
+          <p:cNvPr id="665" name="Google Shape;665;p33:notes"/>
           <p:cNvSpPr txBox="1"/>
           <p:nvPr>
             <p:ph idx="1" type="body"/>
@@ -2555,7 +2555,7 @@
       </p:sp>
       <p:sp>
         <p:nvSpPr>
-          <p:cNvPr id="662" name="Google Shape;662;p33:notes"/>
+          <p:cNvPr id="666" name="Google Shape;666;p33:notes"/>
           <p:cNvSpPr/>
           <p:nvPr>
             <p:ph idx="2" type="sldImg"/>
@@ -2601,7 +2601,7 @@
   <p:cSld>
     <p:spTree>
       <p:nvGrpSpPr>
-        <p:cNvPr id="681" name="Shape 681"/>
+        <p:cNvPr id="685" name="Shape 685"/>
         <p:cNvGrpSpPr/>
         <p:nvPr/>
       </p:nvGrpSpPr>
@@ -2615,7 +2615,7 @@
       </p:grpSpPr>
       <p:sp>
         <p:nvSpPr>
-          <p:cNvPr id="682" name="Google Shape;682;p34:notes"/>
+          <p:cNvPr id="686" name="Google Shape;686;p34:notes"/>
           <p:cNvSpPr txBox="1"/>
           <p:nvPr>
             <p:ph idx="1" type="body"/>
@@ -2654,7 +2654,7 @@
       </p:sp>
       <p:sp>
         <p:nvSpPr>
-          <p:cNvPr id="683" name="Google Shape;683;p34:notes"/>
+          <p:cNvPr id="687" name="Google Shape;687;p34:notes"/>
           <p:cNvSpPr/>
           <p:nvPr>
             <p:ph idx="2" type="sldImg"/>
@@ -2700,7 +2700,7 @@
   <p:cSld>
     <p:spTree>
       <p:nvGrpSpPr>
-        <p:cNvPr id="704" name="Shape 704"/>
+        <p:cNvPr id="708" name="Shape 708"/>
         <p:cNvGrpSpPr/>
         <p:nvPr/>
       </p:nvGrpSpPr>
@@ -2714,7 +2714,7 @@
       </p:grpSpPr>
       <p:sp>
         <p:nvSpPr>
-          <p:cNvPr id="705" name="Google Shape;705;g3f195cdcbda_0_59:notes"/>
+          <p:cNvPr id="709" name="Google Shape;709;g3f195cdcbda_0_59:notes"/>
           <p:cNvSpPr txBox="1"/>
           <p:nvPr>
             <p:ph idx="1" type="body"/>
@@ -2753,7 +2753,7 @@
       </p:sp>
       <p:sp>
         <p:nvSpPr>
-          <p:cNvPr id="706" name="Google Shape;706;g3f195cdcbda_0_59:notes"/>
+          <p:cNvPr id="710" name="Google Shape;710;g3f195cdcbda_0_59:notes"/>
           <p:cNvSpPr/>
           <p:nvPr>
             <p:ph idx="2" type="sldImg"/>
@@ -13637,7 +13637,7 @@
                   <a:cs typeface="Cambria"/>
                   <a:sym typeface="Cambria"/>
                 </a:rPr>
-                <a:t>Johnprice Osagie · Deniz Eren Gencay · Matteo Gastaldello · Erestina Vreto</a:t>
+                <a:t>Johnprice Osagie · Matteo Gastaldello · Erestina Vreto</a:t>
               </a:r>
               <a:endParaRPr sz="1300">
                 <a:solidFill>
@@ -21595,7 +21595,7 @@
                   <a:cs typeface="Cambria"/>
                   <a:sym typeface="Cambria"/>
                 </a:rPr>
-                <a:t>4B vs. 4B</a:t>
+                <a:t>4B vs. 4-4B</a:t>
               </a:r>
               <a:endParaRPr b="1" sz="1200">
                 <a:solidFill>
@@ -23378,7 +23378,19 @@
                     <a:cs typeface="Cambria"/>
                     <a:sym typeface="Cambria"/>
                   </a:rPr>
-                  <a:t>Hybrid architectures reach peak levels (up to 99.9% on Gemma-31B), proving multi-agent verification is key.</a:t>
+                  <a:t>Hybrid architectures reach peak levels </a:t>
+                </a:r>
+                <a:r>
+                  <a:rPr lang="en-US" sz="1100">
+                    <a:solidFill>
+                      <a:srgbClr val="222222"/>
+                    </a:solidFill>
+                    <a:latin typeface="Cambria"/>
+                    <a:ea typeface="Cambria"/>
+                    <a:cs typeface="Cambria"/>
+                    <a:sym typeface="Cambria"/>
+                  </a:rPr>
+                  <a:t>in many models, while the max is achieved by SOA+few_shot in Gemma 31B.</a:t>
                 </a:r>
                 <a:endParaRPr b="0" sz="1100">
                   <a:solidFill>
@@ -26224,7 +26236,7 @@
                     <a:cs typeface="Cambria"/>
                     <a:sym typeface="Cambria"/>
                   </a:rPr>
-                  <a:t> Measures test  behavior, not code quality. Test-suite may miss adversarial inputs. Bimodal distribution.</a:t>
+                  <a:t> Measures test  behavior, not code quality.</a:t>
                 </a:r>
                 <a:endParaRPr sz="1100">
                   <a:solidFill>
@@ -27514,7 +27526,31 @@
                 <a:cs typeface="Cambria"/>
                 <a:sym typeface="Cambria"/>
               </a:rPr>
-              <a:t>Custom Instrumentation: AST parsing &amp; sys.settrace for fine-grained tracking.</a:t>
+              <a:t>Custom Instrumentation: AST parsing</a:t>
+            </a:r>
+            <a:r>
+              <a:rPr lang="en-US" sz="1050">
+                <a:solidFill>
+                  <a:srgbClr val="475569"/>
+                </a:solidFill>
+                <a:latin typeface="Cambria"/>
+                <a:ea typeface="Cambria"/>
+                <a:cs typeface="Cambria"/>
+                <a:sym typeface="Cambria"/>
+              </a:rPr>
+              <a:t> </a:t>
+            </a:r>
+            <a:r>
+              <a:rPr b="0" lang="en-US" sz="1050">
+                <a:solidFill>
+                  <a:srgbClr val="475569"/>
+                </a:solidFill>
+                <a:latin typeface="Cambria"/>
+                <a:ea typeface="Cambria"/>
+                <a:cs typeface="Cambria"/>
+                <a:sym typeface="Cambria"/>
+              </a:rPr>
+              <a:t> for fine-grained tracking.</a:t>
             </a:r>
             <a:endParaRPr b="0" sz="1050">
               <a:solidFill>
@@ -27546,7 +27582,7 @@
                 <a:cs typeface="Cambria"/>
                 <a:sym typeface="Cambria"/>
               </a:rPr>
-              <a:t>Multi-process isolation with hardware kill-switches.</a:t>
+              <a:t>Multi-process isolation with hardware kill-switches (for API rate limits).</a:t>
             </a:r>
             <a:endParaRPr b="0" sz="1050">
               <a:solidFill>
@@ -28176,8 +28212,8 @@
         </p:blipFill>
         <p:spPr>
           <a:xfrm>
-            <a:off x="152400" y="1140780"/>
-            <a:ext cx="11886879" cy="3569546"/>
+            <a:off x="152400" y="1417150"/>
+            <a:ext cx="11643351" cy="3496421"/>
           </a:xfrm>
           <a:prstGeom prst="rect">
             <a:avLst/>
@@ -28188,6 +28224,239 @@
           </a:ln>
         </p:spPr>
       </p:pic>
+      <p:grpSp>
+        <p:nvGrpSpPr>
+          <p:cNvPr id="546" name="Google Shape;546;p33"/>
+          <p:cNvGrpSpPr/>
+          <p:nvPr/>
+        </p:nvGrpSpPr>
+        <p:grpSpPr>
+          <a:xfrm>
+            <a:off x="457200" y="5362626"/>
+            <a:ext cx="11277600" cy="400207"/>
+            <a:chOff x="457200" y="5095875"/>
+            <a:chExt cx="11277600" cy="666900"/>
+          </a:xfrm>
+        </p:grpSpPr>
+        <p:sp>
+          <p:nvSpPr>
+            <p:cNvPr id="547" name="Google Shape;547;p33"/>
+            <p:cNvSpPr/>
+            <p:nvPr/>
+          </p:nvSpPr>
+          <p:spPr>
+            <a:xfrm>
+              <a:off x="457200" y="5095875"/>
+              <a:ext cx="11277600" cy="666900"/>
+            </a:xfrm>
+            <a:prstGeom prst="roundRect">
+              <a:avLst>
+                <a:gd fmla="val 11428" name="adj"/>
+              </a:avLst>
+            </a:prstGeom>
+            <a:solidFill>
+              <a:srgbClr val="EFF6FF"/>
+            </a:solidFill>
+            <a:ln cap="flat" cmpd="sng" w="9525">
+              <a:solidFill>
+                <a:srgbClr val="3B82F6"/>
+              </a:solidFill>
+              <a:prstDash val="solid"/>
+              <a:round/>
+              <a:headEnd len="sm" w="sm" type="none"/>
+              <a:tailEnd len="sm" w="sm" type="none"/>
+            </a:ln>
+          </p:spPr>
+          <p:txBody>
+            <a:bodyPr anchorCtr="0" anchor="ctr" bIns="0" lIns="0" spcFirstLastPara="1" rIns="0" wrap="square" tIns="0">
+              <a:noAutofit/>
+            </a:bodyPr>
+            <a:lstStyle/>
+            <a:p>
+              <a:pPr indent="0" lvl="0" marL="0" rtl="0" algn="l">
+                <a:spcBef>
+                  <a:spcPts val="0"/>
+                </a:spcBef>
+                <a:spcAft>
+                  <a:spcPts val="0"/>
+                </a:spcAft>
+                <a:buNone/>
+              </a:pPr>
+              <a:r>
+                <a:t/>
+              </a:r>
+              <a:endParaRPr/>
+            </a:p>
+          </p:txBody>
+        </p:sp>
+        <p:sp>
+          <p:nvSpPr>
+            <p:cNvPr id="548" name="Google Shape;548;p33"/>
+            <p:cNvSpPr txBox="1"/>
+            <p:nvPr/>
+          </p:nvSpPr>
+          <p:spPr>
+            <a:xfrm>
+              <a:off x="647700" y="5095875"/>
+              <a:ext cx="10896600" cy="666900"/>
+            </a:xfrm>
+            <a:prstGeom prst="rect">
+              <a:avLst/>
+            </a:prstGeom>
+            <a:noFill/>
+            <a:ln>
+              <a:noFill/>
+            </a:ln>
+          </p:spPr>
+          <p:txBody>
+            <a:bodyPr anchorCtr="0" anchor="ctr" bIns="0" lIns="0" spcFirstLastPara="1" rIns="0" wrap="square" tIns="0">
+              <a:noAutofit/>
+            </a:bodyPr>
+            <a:lstStyle/>
+            <a:p>
+              <a:pPr indent="0" lvl="0" marL="0" rtl="0" algn="l">
+                <a:spcBef>
+                  <a:spcPts val="0"/>
+                </a:spcBef>
+                <a:spcAft>
+                  <a:spcPts val="0"/>
+                </a:spcAft>
+                <a:buNone/>
+              </a:pPr>
+              <a:r>
+                <a:rPr b="1" lang="en-US" sz="1100">
+                  <a:solidFill>
+                    <a:srgbClr val="1E40AF"/>
+                  </a:solidFill>
+                  <a:latin typeface="Cambria"/>
+                  <a:ea typeface="Cambria"/>
+                  <a:cs typeface="Cambria"/>
+                  <a:sym typeface="Cambria"/>
+                </a:rPr>
+                <a:t>Observation: </a:t>
+              </a:r>
+              <a:r>
+                <a:rPr lang="en-US" sz="1100">
+                  <a:solidFill>
+                    <a:srgbClr val="1E40AF"/>
+                  </a:solidFill>
+                  <a:latin typeface="Cambria"/>
+                  <a:ea typeface="Cambria"/>
+                  <a:cs typeface="Cambria"/>
+                  <a:sym typeface="Cambria"/>
+                </a:rPr>
+                <a:t>This is the metric where the generational gap is shown the most.</a:t>
+              </a:r>
+              <a:endParaRPr b="1" sz="1100">
+                <a:solidFill>
+                  <a:srgbClr val="1E40AF"/>
+                </a:solidFill>
+                <a:latin typeface="Cambria"/>
+                <a:ea typeface="Cambria"/>
+                <a:cs typeface="Cambria"/>
+                <a:sym typeface="Cambria"/>
+              </a:endParaRPr>
+            </a:p>
+          </p:txBody>
+        </p:sp>
+      </p:grpSp>
+      <p:sp>
+        <p:nvSpPr>
+          <p:cNvPr id="549" name="Google Shape;549;p33"/>
+          <p:cNvSpPr/>
+          <p:nvPr/>
+        </p:nvSpPr>
+        <p:spPr>
+          <a:xfrm>
+            <a:off x="457200" y="5857875"/>
+            <a:ext cx="11277600" cy="428700"/>
+          </a:xfrm>
+          <a:prstGeom prst="roundRect">
+            <a:avLst>
+              <a:gd fmla="val 17777" name="adj"/>
+            </a:avLst>
+          </a:prstGeom>
+          <a:solidFill>
+            <a:srgbClr val="FFF1F2"/>
+          </a:solidFill>
+          <a:ln cap="flat" cmpd="sng" w="9525">
+            <a:solidFill>
+              <a:srgbClr val="FECDD3"/>
+            </a:solidFill>
+            <a:prstDash val="solid"/>
+            <a:round/>
+            <a:headEnd len="sm" w="sm" type="none"/>
+            <a:tailEnd len="sm" w="sm" type="none"/>
+          </a:ln>
+        </p:spPr>
+        <p:txBody>
+          <a:bodyPr anchorCtr="0" anchor="ctr" bIns="0" lIns="0" spcFirstLastPara="1" rIns="0" wrap="square" tIns="0">
+            <a:noAutofit/>
+          </a:bodyPr>
+          <a:lstStyle/>
+          <a:p>
+            <a:pPr indent="0" lvl="0" marL="0" rtl="0" algn="l">
+              <a:spcBef>
+                <a:spcPts val="0"/>
+              </a:spcBef>
+              <a:spcAft>
+                <a:spcPts val="0"/>
+              </a:spcAft>
+              <a:buClr>
+                <a:schemeClr val="dk1"/>
+              </a:buClr>
+              <a:buSzPts val="1100"/>
+              <a:buFont typeface="Arial"/>
+              <a:buNone/>
+            </a:pPr>
+            <a:r>
+              <a:rPr b="1" lang="en-US" sz="1100">
+                <a:solidFill>
+                  <a:srgbClr val="9F1239"/>
+                </a:solidFill>
+                <a:latin typeface="Cambria"/>
+                <a:ea typeface="Cambria"/>
+                <a:cs typeface="Cambria"/>
+                <a:sym typeface="Cambria"/>
+              </a:rPr>
+              <a:t>     Take-away</a:t>
+            </a:r>
+            <a:r>
+              <a:rPr b="1" lang="en-US" sz="1100">
+                <a:solidFill>
+                  <a:srgbClr val="9F1239"/>
+                </a:solidFill>
+                <a:latin typeface="Cambria"/>
+                <a:ea typeface="Cambria"/>
+                <a:cs typeface="Cambria"/>
+                <a:sym typeface="Cambria"/>
+              </a:rPr>
+              <a:t>:</a:t>
+            </a:r>
+            <a:r>
+              <a:rPr lang="en-US" sz="1100">
+                <a:solidFill>
+                  <a:srgbClr val="9F1239"/>
+                </a:solidFill>
+                <a:latin typeface="Cambria"/>
+                <a:ea typeface="Cambria"/>
+                <a:cs typeface="Cambria"/>
+                <a:sym typeface="Cambria"/>
+              </a:rPr>
+              <a:t> Baseline performs best, zero-shot and actor-critic underperforms.</a:t>
+            </a:r>
+            <a:endParaRPr sz="1100">
+              <a:solidFill>
+                <a:srgbClr val="9F1239"/>
+              </a:solidFill>
+              <a:latin typeface="Cambria"/>
+              <a:ea typeface="Cambria"/>
+              <a:cs typeface="Cambria"/>
+              <a:sym typeface="Cambria"/>
+            </a:endParaRPr>
+          </a:p>
+        </p:txBody>
+      </p:sp>
     </p:spTree>
   </p:cSld>
   <p:clrMapOvr>
@@ -28208,7 +28477,7 @@
     </p:bg>
     <p:spTree>
       <p:nvGrpSpPr>
-        <p:cNvPr id="549" name="Shape 549"/>
+        <p:cNvPr id="553" name="Shape 553"/>
         <p:cNvGrpSpPr/>
         <p:nvPr/>
       </p:nvGrpSpPr>
@@ -28222,7 +28491,7 @@
       </p:grpSpPr>
       <p:pic>
         <p:nvPicPr>
-          <p:cNvPr descr="polito_logo.png" id="550" name="Google Shape;550;p34"/>
+          <p:cNvPr descr="polito_logo.png" id="554" name="Google Shape;554;p34"/>
           <p:cNvPicPr preferRelativeResize="0"/>
           <p:nvPr/>
         </p:nvPicPr>
@@ -28249,7 +28518,7 @@
       </p:pic>
       <p:sp>
         <p:nvSpPr>
-          <p:cNvPr id="551" name="Google Shape;551;p34"/>
+          <p:cNvPr id="555" name="Google Shape;555;p34"/>
           <p:cNvSpPr txBox="1"/>
           <p:nvPr/>
         </p:nvSpPr>
@@ -28299,7 +28568,7 @@
       </p:sp>
       <p:sp>
         <p:nvSpPr>
-          <p:cNvPr id="552" name="Google Shape;552;p34"/>
+          <p:cNvPr id="556" name="Google Shape;556;p34"/>
           <p:cNvSpPr txBox="1"/>
           <p:nvPr/>
         </p:nvSpPr>
@@ -28349,7 +28618,7 @@
       </p:sp>
       <p:sp>
         <p:nvSpPr>
-          <p:cNvPr id="553" name="Google Shape;553;p34"/>
+          <p:cNvPr id="557" name="Google Shape;557;p34"/>
           <p:cNvSpPr txBox="1"/>
           <p:nvPr/>
         </p:nvSpPr>
@@ -28399,7 +28668,7 @@
       </p:sp>
       <p:sp>
         <p:nvSpPr>
-          <p:cNvPr id="554" name="Google Shape;554;p34"/>
+          <p:cNvPr id="558" name="Google Shape;558;p34"/>
           <p:cNvSpPr txBox="1"/>
           <p:nvPr/>
         </p:nvSpPr>
@@ -28473,7 +28742,7 @@
       </p:sp>
       <p:sp>
         <p:nvSpPr>
-          <p:cNvPr id="555" name="Google Shape;555;p34"/>
+          <p:cNvPr id="559" name="Google Shape;559;p34"/>
           <p:cNvSpPr/>
           <p:nvPr/>
         </p:nvSpPr>
@@ -28531,7 +28800,7 @@
       </p:sp>
       <p:sp>
         <p:nvSpPr>
-          <p:cNvPr id="556" name="Google Shape;556;p34"/>
+          <p:cNvPr id="560" name="Google Shape;560;p34"/>
           <p:cNvSpPr/>
           <p:nvPr/>
         </p:nvSpPr>
@@ -28589,7 +28858,7 @@
       </p:sp>
       <p:grpSp>
         <p:nvGrpSpPr>
-          <p:cNvPr id="557" name="Google Shape;557;p34"/>
+          <p:cNvPr id="561" name="Google Shape;561;p34"/>
           <p:cNvGrpSpPr/>
           <p:nvPr/>
         </p:nvGrpSpPr>
@@ -28603,7 +28872,7 @@
         </p:grpSpPr>
         <p:sp>
           <p:nvSpPr>
-            <p:cNvPr id="558" name="Google Shape;558;p34"/>
+            <p:cNvPr id="562" name="Google Shape;562;p34"/>
             <p:cNvSpPr/>
             <p:nvPr/>
           </p:nvSpPr>
@@ -28654,7 +28923,7 @@
         </p:sp>
         <p:sp>
           <p:nvSpPr>
-            <p:cNvPr id="559" name="Google Shape;559;p34"/>
+            <p:cNvPr id="563" name="Google Shape;563;p34"/>
             <p:cNvSpPr txBox="1"/>
             <p:nvPr/>
           </p:nvSpPr>
@@ -28980,7 +29249,7 @@
         </p:sp>
         <p:sp>
           <p:nvSpPr>
-            <p:cNvPr id="560" name="Google Shape;560;p34"/>
+            <p:cNvPr id="564" name="Google Shape;564;p34"/>
             <p:cNvSpPr/>
             <p:nvPr/>
           </p:nvSpPr>
@@ -29031,7 +29300,7 @@
         </p:sp>
         <p:sp>
           <p:nvSpPr>
-            <p:cNvPr id="561" name="Google Shape;561;p34"/>
+            <p:cNvPr id="565" name="Google Shape;565;p34"/>
             <p:cNvSpPr txBox="1"/>
             <p:nvPr/>
           </p:nvSpPr>
@@ -29159,7 +29428,7 @@
                   <a:cs typeface="Cambria"/>
                   <a:sym typeface="Cambria"/>
                 </a:rPr>
-                <a:t>Coverage vs. Correctness (≈ 0.72)</a:t>
+                <a:t>Coverage vs. PassRate (≈ 0.72)</a:t>
               </a:r>
               <a:endParaRPr b="1" sz="1100">
                 <a:solidFill>
@@ -29296,7 +29565,7 @@
       </p:grpSp>
       <p:sp>
         <p:nvSpPr>
-          <p:cNvPr id="562" name="Google Shape;562;p34"/>
+          <p:cNvPr id="566" name="Google Shape;566;p34"/>
           <p:cNvSpPr/>
           <p:nvPr/>
         </p:nvSpPr>
@@ -29354,7 +29623,7 @@
       </p:sp>
       <p:grpSp>
         <p:nvGrpSpPr>
-          <p:cNvPr id="563" name="Google Shape;563;p34"/>
+          <p:cNvPr id="567" name="Google Shape;567;p34"/>
           <p:cNvGrpSpPr/>
           <p:nvPr/>
         </p:nvGrpSpPr>
@@ -29368,7 +29637,7 @@
         </p:grpSpPr>
         <p:sp>
           <p:nvSpPr>
-            <p:cNvPr id="564" name="Google Shape;564;p34"/>
+            <p:cNvPr id="568" name="Google Shape;568;p34"/>
             <p:cNvSpPr/>
             <p:nvPr/>
           </p:nvSpPr>
@@ -29419,7 +29688,7 @@
         </p:sp>
         <p:sp>
           <p:nvSpPr>
-            <p:cNvPr id="565" name="Google Shape;565;p34"/>
+            <p:cNvPr id="569" name="Google Shape;569;p34"/>
             <p:cNvSpPr txBox="1"/>
             <p:nvPr/>
           </p:nvSpPr>
@@ -29473,7 +29742,31 @@
                   <a:cs typeface="Cambria"/>
                   <a:sym typeface="Cambria"/>
                 </a:rPr>
-                <a:t>Coverage is necessary but not sufficient. It measures breadth, while mutation measures depth. Atomic Swarm can hit ~100% on buggy code via circular tests.</a:t>
+                <a:t>Coverage is necessary but not sufficient. It measures breadth, while mutation measures depth.</a:t>
+              </a:r>
+              <a:r>
+                <a:rPr lang="en-US" sz="1100">
+                  <a:solidFill>
+                    <a:srgbClr val="9F1239"/>
+                  </a:solidFill>
+                  <a:latin typeface="Cambria"/>
+                  <a:ea typeface="Cambria"/>
+                  <a:cs typeface="Cambria"/>
+                  <a:sym typeface="Cambria"/>
+                </a:rPr>
+                <a:t> </a:t>
+              </a:r>
+              <a:r>
+                <a:rPr b="0" lang="en-US" sz="1100">
+                  <a:solidFill>
+                    <a:srgbClr val="9F1239"/>
+                  </a:solidFill>
+                  <a:latin typeface="Cambria"/>
+                  <a:ea typeface="Cambria"/>
+                  <a:cs typeface="Cambria"/>
+                  <a:sym typeface="Cambria"/>
+                </a:rPr>
+                <a:t> Atomic Swarm can hit ~100% on buggy code via circular tests.</a:t>
               </a:r>
               <a:endParaRPr b="1" sz="1100">
                 <a:solidFill>
@@ -29490,7 +29783,7 @@
       </p:grpSp>
       <p:sp>
         <p:nvSpPr>
-          <p:cNvPr id="566" name="Google Shape;566;p34"/>
+          <p:cNvPr id="570" name="Google Shape;570;p34"/>
           <p:cNvSpPr txBox="1"/>
           <p:nvPr/>
         </p:nvSpPr>
@@ -29540,7 +29833,7 @@
       </p:sp>
       <p:pic>
         <p:nvPicPr>
-          <p:cNvPr id="567" name="Google Shape;567;p34"/>
+          <p:cNvPr id="571" name="Google Shape;571;p34"/>
           <p:cNvPicPr preferRelativeResize="0"/>
           <p:nvPr/>
         </p:nvPicPr>
@@ -29568,7 +29861,7 @@
       </p:pic>
       <p:pic>
         <p:nvPicPr>
-          <p:cNvPr id="568" name="Google Shape;568;p34"/>
+          <p:cNvPr id="572" name="Google Shape;572;p34"/>
           <p:cNvPicPr preferRelativeResize="0"/>
           <p:nvPr/>
         </p:nvPicPr>
@@ -29619,7 +29912,7 @@
     </p:bg>
     <p:spTree>
       <p:nvGrpSpPr>
-        <p:cNvPr id="572" name="Shape 572"/>
+        <p:cNvPr id="576" name="Shape 576"/>
         <p:cNvGrpSpPr/>
         <p:nvPr/>
       </p:nvGrpSpPr>
@@ -29633,7 +29926,7 @@
       </p:grpSpPr>
       <p:pic>
         <p:nvPicPr>
-          <p:cNvPr descr="polito_logo.png" id="573" name="Google Shape;573;p35"/>
+          <p:cNvPr descr="polito_logo.png" id="577" name="Google Shape;577;p35"/>
           <p:cNvPicPr preferRelativeResize="0"/>
           <p:nvPr/>
         </p:nvPicPr>
@@ -29660,7 +29953,7 @@
       </p:pic>
       <p:sp>
         <p:nvSpPr>
-          <p:cNvPr id="574" name="Google Shape;574;p35"/>
+          <p:cNvPr id="578" name="Google Shape;578;p35"/>
           <p:cNvSpPr txBox="1"/>
           <p:nvPr/>
         </p:nvSpPr>
@@ -29710,7 +30003,7 @@
       </p:sp>
       <p:sp>
         <p:nvSpPr>
-          <p:cNvPr id="575" name="Google Shape;575;p35"/>
+          <p:cNvPr id="579" name="Google Shape;579;p35"/>
           <p:cNvSpPr txBox="1"/>
           <p:nvPr/>
         </p:nvSpPr>
@@ -29760,7 +30053,7 @@
       </p:sp>
       <p:sp>
         <p:nvSpPr>
-          <p:cNvPr id="576" name="Google Shape;576;p35"/>
+          <p:cNvPr id="580" name="Google Shape;580;p35"/>
           <p:cNvSpPr txBox="1"/>
           <p:nvPr/>
         </p:nvSpPr>
@@ -29834,7 +30127,7 @@
       </p:sp>
       <p:sp>
         <p:nvSpPr>
-          <p:cNvPr id="577" name="Google Shape;577;p35"/>
+          <p:cNvPr id="581" name="Google Shape;581;p35"/>
           <p:cNvSpPr/>
           <p:nvPr/>
         </p:nvSpPr>
@@ -29892,7 +30185,7 @@
       </p:sp>
       <p:sp>
         <p:nvSpPr>
-          <p:cNvPr id="578" name="Google Shape;578;p35"/>
+          <p:cNvPr id="582" name="Google Shape;582;p35"/>
           <p:cNvSpPr/>
           <p:nvPr/>
         </p:nvSpPr>
@@ -29950,7 +30243,7 @@
       </p:sp>
       <p:sp>
         <p:nvSpPr>
-          <p:cNvPr id="579" name="Google Shape;579;p35"/>
+          <p:cNvPr id="583" name="Google Shape;583;p35"/>
           <p:cNvSpPr/>
           <p:nvPr/>
         </p:nvSpPr>
@@ -30008,7 +30301,7 @@
       </p:sp>
       <p:sp>
         <p:nvSpPr>
-          <p:cNvPr id="580" name="Google Shape;580;p35"/>
+          <p:cNvPr id="584" name="Google Shape;584;p35"/>
           <p:cNvSpPr txBox="1"/>
           <p:nvPr/>
         </p:nvSpPr>
@@ -30058,7 +30351,7 @@
       </p:sp>
       <p:grpSp>
         <p:nvGrpSpPr>
-          <p:cNvPr id="581" name="Google Shape;581;p35"/>
+          <p:cNvPr id="585" name="Google Shape;585;p35"/>
           <p:cNvGrpSpPr/>
           <p:nvPr/>
         </p:nvGrpSpPr>
@@ -30072,7 +30365,7 @@
         </p:grpSpPr>
         <p:sp>
           <p:nvSpPr>
-            <p:cNvPr id="582" name="Google Shape;582;p35"/>
+            <p:cNvPr id="586" name="Google Shape;586;p35"/>
             <p:cNvSpPr/>
             <p:nvPr/>
           </p:nvSpPr>
@@ -30123,7 +30416,7 @@
         </p:sp>
         <p:pic>
           <p:nvPicPr>
-            <p:cNvPr id="583" name="Google Shape;583;p35" title="fc_baseline_vs_best.png"/>
+            <p:cNvPr id="587" name="Google Shape;587;p35" title="fc_baseline_vs_best.png"/>
             <p:cNvPicPr preferRelativeResize="0"/>
             <p:nvPr/>
           </p:nvPicPr>
@@ -30150,7 +30443,7 @@
         </p:pic>
         <p:grpSp>
           <p:nvGrpSpPr>
-            <p:cNvPr id="584" name="Google Shape;584;p35"/>
+            <p:cNvPr id="588" name="Google Shape;588;p35"/>
             <p:cNvGrpSpPr/>
             <p:nvPr/>
           </p:nvGrpSpPr>
@@ -30164,7 +30457,7 @@
           </p:grpSpPr>
           <p:sp>
             <p:nvSpPr>
-              <p:cNvPr id="585" name="Google Shape;585;p35"/>
+              <p:cNvPr id="589" name="Google Shape;589;p35"/>
               <p:cNvSpPr/>
               <p:nvPr/>
             </p:nvSpPr>
@@ -30215,7 +30508,7 @@
           </p:sp>
           <p:sp>
             <p:nvSpPr>
-              <p:cNvPr id="586" name="Google Shape;586;p35"/>
+              <p:cNvPr id="590" name="Google Shape;590;p35"/>
               <p:cNvSpPr txBox="1"/>
               <p:nvPr/>
             </p:nvSpPr>
@@ -30390,7 +30683,7 @@
       </p:grpSp>
       <p:sp>
         <p:nvSpPr>
-          <p:cNvPr id="587" name="Google Shape;587;p35"/>
+          <p:cNvPr id="591" name="Google Shape;591;p35"/>
           <p:cNvSpPr txBox="1"/>
           <p:nvPr/>
         </p:nvSpPr>
@@ -30464,7 +30757,7 @@
       </p:sp>
       <p:sp>
         <p:nvSpPr>
-          <p:cNvPr id="588" name="Google Shape;588;p35"/>
+          <p:cNvPr id="592" name="Google Shape;592;p35"/>
           <p:cNvSpPr/>
           <p:nvPr/>
         </p:nvSpPr>
@@ -30515,7 +30808,7 @@
       </p:sp>
       <p:sp>
         <p:nvSpPr>
-          <p:cNvPr id="589" name="Google Shape;589;p35"/>
+          <p:cNvPr id="593" name="Google Shape;593;p35"/>
           <p:cNvSpPr txBox="1"/>
           <p:nvPr/>
         </p:nvSpPr>
@@ -30607,7 +30900,7 @@
     </p:bg>
     <p:spTree>
       <p:nvGrpSpPr>
-        <p:cNvPr id="593" name="Shape 593"/>
+        <p:cNvPr id="597" name="Shape 597"/>
         <p:cNvGrpSpPr/>
         <p:nvPr/>
       </p:nvGrpSpPr>
@@ -30621,7 +30914,7 @@
       </p:grpSpPr>
       <p:pic>
         <p:nvPicPr>
-          <p:cNvPr descr="polito_logo.png" id="594" name="Google Shape;594;p36"/>
+          <p:cNvPr descr="polito_logo.png" id="598" name="Google Shape;598;p36"/>
           <p:cNvPicPr preferRelativeResize="0"/>
           <p:nvPr/>
         </p:nvPicPr>
@@ -30648,7 +30941,7 @@
       </p:pic>
       <p:sp>
         <p:nvSpPr>
-          <p:cNvPr id="595" name="Google Shape;595;p36"/>
+          <p:cNvPr id="599" name="Google Shape;599;p36"/>
           <p:cNvSpPr txBox="1"/>
           <p:nvPr/>
         </p:nvSpPr>
@@ -30698,7 +30991,7 @@
       </p:sp>
       <p:sp>
         <p:nvSpPr>
-          <p:cNvPr id="596" name="Google Shape;596;p36"/>
+          <p:cNvPr id="600" name="Google Shape;600;p36"/>
           <p:cNvSpPr txBox="1"/>
           <p:nvPr/>
         </p:nvSpPr>
@@ -30748,7 +31041,7 @@
       </p:sp>
       <p:sp>
         <p:nvSpPr>
-          <p:cNvPr id="597" name="Google Shape;597;p36"/>
+          <p:cNvPr id="601" name="Google Shape;601;p36"/>
           <p:cNvSpPr txBox="1"/>
           <p:nvPr/>
         </p:nvSpPr>
@@ -30798,7 +31091,7 @@
       </p:sp>
       <p:sp>
         <p:nvSpPr>
-          <p:cNvPr id="598" name="Google Shape;598;p36"/>
+          <p:cNvPr id="602" name="Google Shape;602;p36"/>
           <p:cNvSpPr txBox="1"/>
           <p:nvPr/>
         </p:nvSpPr>
@@ -30872,7 +31165,7 @@
       </p:sp>
       <p:sp>
         <p:nvSpPr>
-          <p:cNvPr id="599" name="Google Shape;599;p36"/>
+          <p:cNvPr id="603" name="Google Shape;603;p36"/>
           <p:cNvSpPr/>
           <p:nvPr/>
         </p:nvSpPr>
@@ -30930,7 +31223,7 @@
       </p:sp>
       <p:sp>
         <p:nvSpPr>
-          <p:cNvPr id="600" name="Google Shape;600;p36"/>
+          <p:cNvPr id="604" name="Google Shape;604;p36"/>
           <p:cNvSpPr/>
           <p:nvPr/>
         </p:nvSpPr>
@@ -30988,7 +31281,7 @@
       </p:sp>
       <p:grpSp>
         <p:nvGrpSpPr>
-          <p:cNvPr id="601" name="Google Shape;601;p36"/>
+          <p:cNvPr id="605" name="Google Shape;605;p36"/>
           <p:cNvGrpSpPr/>
           <p:nvPr/>
         </p:nvGrpSpPr>
@@ -31002,7 +31295,7 @@
         </p:grpSpPr>
         <p:sp>
           <p:nvSpPr>
-            <p:cNvPr id="602" name="Google Shape;602;p36"/>
+            <p:cNvPr id="606" name="Google Shape;606;p36"/>
             <p:cNvSpPr/>
             <p:nvPr/>
           </p:nvSpPr>
@@ -31049,7 +31342,7 @@
         </p:sp>
         <p:sp>
           <p:nvSpPr>
-            <p:cNvPr id="603" name="Google Shape;603;p36"/>
+            <p:cNvPr id="607" name="Google Shape;607;p36"/>
             <p:cNvSpPr/>
             <p:nvPr/>
           </p:nvSpPr>
@@ -31096,7 +31389,7 @@
         </p:sp>
         <p:pic>
           <p:nvPicPr>
-            <p:cNvPr id="604" name="Google Shape;604;p36" title="avg_agent.png"/>
+            <p:cNvPr id="608" name="Google Shape;608;p36" title="avg_agent.png"/>
             <p:cNvPicPr preferRelativeResize="0"/>
             <p:nvPr/>
           </p:nvPicPr>
@@ -31125,7 +31418,7 @@
         </p:pic>
         <p:pic>
           <p:nvPicPr>
-            <p:cNvPr id="605" name="Google Shape;605;p36" title="avg_prompt_style.png"/>
+            <p:cNvPr id="609" name="Google Shape;609;p36" title="avg_prompt_style.png"/>
             <p:cNvPicPr preferRelativeResize="0"/>
             <p:nvPr/>
           </p:nvPicPr>
@@ -31154,7 +31447,7 @@
         </p:pic>
         <p:grpSp>
           <p:nvGrpSpPr>
-            <p:cNvPr id="606" name="Google Shape;606;p36"/>
+            <p:cNvPr id="610" name="Google Shape;610;p36"/>
             <p:cNvGrpSpPr/>
             <p:nvPr/>
           </p:nvGrpSpPr>
@@ -31168,7 +31461,7 @@
           </p:grpSpPr>
           <p:sp>
             <p:nvSpPr>
-              <p:cNvPr id="607" name="Google Shape;607;p36"/>
+              <p:cNvPr id="611" name="Google Shape;611;p36"/>
               <p:cNvSpPr/>
               <p:nvPr/>
             </p:nvSpPr>
@@ -31219,7 +31512,7 @@
           </p:sp>
           <p:sp>
             <p:nvSpPr>
-              <p:cNvPr id="608" name="Google Shape;608;p36"/>
+              <p:cNvPr id="612" name="Google Shape;612;p36"/>
               <p:cNvSpPr txBox="1"/>
               <p:nvPr/>
             </p:nvSpPr>
@@ -31367,7 +31660,7 @@
       </p:grpSp>
       <p:sp>
         <p:nvSpPr>
-          <p:cNvPr id="609" name="Google Shape;609;p36"/>
+          <p:cNvPr id="613" name="Google Shape;613;p36"/>
           <p:cNvSpPr/>
           <p:nvPr/>
         </p:nvSpPr>
@@ -31425,7 +31718,7 @@
       </p:sp>
       <p:sp>
         <p:nvSpPr>
-          <p:cNvPr id="610" name="Google Shape;610;p36"/>
+          <p:cNvPr id="614" name="Google Shape;614;p36"/>
           <p:cNvSpPr txBox="1"/>
           <p:nvPr/>
         </p:nvSpPr>
@@ -31493,7 +31786,7 @@
     </p:bg>
     <p:spTree>
       <p:nvGrpSpPr>
-        <p:cNvPr id="614" name="Shape 614"/>
+        <p:cNvPr id="618" name="Shape 618"/>
         <p:cNvGrpSpPr/>
         <p:nvPr/>
       </p:nvGrpSpPr>
@@ -31507,7 +31800,7 @@
       </p:grpSpPr>
       <p:pic>
         <p:nvPicPr>
-          <p:cNvPr descr="polito_logo.png" id="615" name="Google Shape;615;p37"/>
+          <p:cNvPr descr="polito_logo.png" id="619" name="Google Shape;619;p37"/>
           <p:cNvPicPr preferRelativeResize="0"/>
           <p:nvPr/>
         </p:nvPicPr>
@@ -31534,7 +31827,7 @@
       </p:pic>
       <p:sp>
         <p:nvSpPr>
-          <p:cNvPr id="616" name="Google Shape;616;p37"/>
+          <p:cNvPr id="620" name="Google Shape;620;p37"/>
           <p:cNvSpPr txBox="1"/>
           <p:nvPr/>
         </p:nvSpPr>
@@ -31584,7 +31877,7 @@
       </p:sp>
       <p:sp>
         <p:nvSpPr>
-          <p:cNvPr id="617" name="Google Shape;617;p37"/>
+          <p:cNvPr id="621" name="Google Shape;621;p37"/>
           <p:cNvSpPr txBox="1"/>
           <p:nvPr/>
         </p:nvSpPr>
@@ -31634,7 +31927,7 @@
       </p:sp>
       <p:sp>
         <p:nvSpPr>
-          <p:cNvPr id="618" name="Google Shape;618;p37"/>
+          <p:cNvPr id="622" name="Google Shape;622;p37"/>
           <p:cNvSpPr txBox="1"/>
           <p:nvPr/>
         </p:nvSpPr>
@@ -31684,7 +31977,7 @@
       </p:sp>
       <p:sp>
         <p:nvSpPr>
-          <p:cNvPr id="619" name="Google Shape;619;p37"/>
+          <p:cNvPr id="623" name="Google Shape;623;p37"/>
           <p:cNvSpPr txBox="1"/>
           <p:nvPr/>
         </p:nvSpPr>
@@ -31734,7 +32027,7 @@
       </p:sp>
       <p:sp>
         <p:nvSpPr>
-          <p:cNvPr id="620" name="Google Shape;620;p37"/>
+          <p:cNvPr id="624" name="Google Shape;624;p37"/>
           <p:cNvSpPr/>
           <p:nvPr/>
         </p:nvSpPr>
@@ -31792,7 +32085,7 @@
       </p:sp>
       <p:sp>
         <p:nvSpPr>
-          <p:cNvPr id="621" name="Google Shape;621;p37"/>
+          <p:cNvPr id="625" name="Google Shape;625;p37"/>
           <p:cNvSpPr/>
           <p:nvPr/>
         </p:nvSpPr>
@@ -31850,7 +32143,7 @@
       </p:sp>
       <p:grpSp>
         <p:nvGrpSpPr>
-          <p:cNvPr id="622" name="Google Shape;622;p37"/>
+          <p:cNvPr id="626" name="Google Shape;626;p37"/>
           <p:cNvGrpSpPr/>
           <p:nvPr/>
         </p:nvGrpSpPr>
@@ -31864,7 +32157,7 @@
         </p:grpSpPr>
         <p:sp>
           <p:nvSpPr>
-            <p:cNvPr id="623" name="Google Shape;623;p37"/>
+            <p:cNvPr id="627" name="Google Shape;627;p37"/>
             <p:cNvSpPr/>
             <p:nvPr/>
           </p:nvSpPr>
@@ -31911,7 +32204,7 @@
         </p:sp>
         <p:sp>
           <p:nvSpPr>
-            <p:cNvPr id="624" name="Google Shape;624;p37"/>
+            <p:cNvPr id="628" name="Google Shape;628;p37"/>
             <p:cNvSpPr txBox="1"/>
             <p:nvPr/>
           </p:nvSpPr>
@@ -32006,7 +32299,7 @@
       </p:grpSp>
       <p:grpSp>
         <p:nvGrpSpPr>
-          <p:cNvPr id="625" name="Google Shape;625;p37"/>
+          <p:cNvPr id="629" name="Google Shape;629;p37"/>
           <p:cNvGrpSpPr/>
           <p:nvPr/>
         </p:nvGrpSpPr>
@@ -32020,7 +32313,7 @@
         </p:grpSpPr>
         <p:sp>
           <p:nvSpPr>
-            <p:cNvPr id="626" name="Google Shape;626;p37"/>
+            <p:cNvPr id="630" name="Google Shape;630;p37"/>
             <p:cNvSpPr/>
             <p:nvPr/>
           </p:nvSpPr>
@@ -32071,7 +32364,7 @@
         </p:sp>
         <p:sp>
           <p:nvSpPr>
-            <p:cNvPr id="627" name="Google Shape;627;p37"/>
+            <p:cNvPr id="631" name="Google Shape;631;p37"/>
             <p:cNvSpPr txBox="1"/>
             <p:nvPr/>
           </p:nvSpPr>
@@ -32154,7 +32447,31 @@
                   <a:cs typeface="Cambria"/>
                   <a:sym typeface="Cambria"/>
                 </a:rPr>
-                <a:t>Agent design outperforms model scale (e.g., 27B Judge vs. 12B)</a:t>
+                <a:t>Agent design </a:t>
+              </a:r>
+              <a:r>
+                <a:rPr lang="en-US" sz="1200">
+                  <a:solidFill>
+                    <a:srgbClr val="222222"/>
+                  </a:solidFill>
+                  <a:latin typeface="Cambria"/>
+                  <a:ea typeface="Cambria"/>
+                  <a:cs typeface="Cambria"/>
+                  <a:sym typeface="Cambria"/>
+                </a:rPr>
+                <a:t>can bridge</a:t>
+              </a:r>
+              <a:r>
+                <a:rPr b="0" i="0" lang="en-US" sz="1200" u="none" strike="noStrike">
+                  <a:solidFill>
+                    <a:srgbClr val="222222"/>
+                  </a:solidFill>
+                  <a:latin typeface="Cambria"/>
+                  <a:ea typeface="Cambria"/>
+                  <a:cs typeface="Cambria"/>
+                  <a:sym typeface="Cambria"/>
+                </a:rPr>
+                <a:t> model scale </a:t>
               </a:r>
               <a:endParaRPr b="1" i="0" sz="1500" u="none" strike="noStrike">
                 <a:solidFill>
@@ -32227,7 +32544,19 @@
                   <a:cs typeface="Cambria"/>
                   <a:sym typeface="Cambria"/>
                 </a:rPr>
-                <a:t>Pass Rate</a:t>
+                <a:t>Pass Rate </a:t>
+              </a:r>
+              <a:r>
+                <a:rPr lang="en-US" sz="1200">
+                  <a:solidFill>
+                    <a:srgbClr val="222222"/>
+                  </a:solidFill>
+                  <a:latin typeface="Cambria"/>
+                  <a:ea typeface="Cambria"/>
+                  <a:cs typeface="Cambria"/>
+                  <a:sym typeface="Cambria"/>
+                </a:rPr>
+                <a:t> ≠ Mutation score</a:t>
               </a:r>
               <a:endParaRPr b="1" i="0" sz="1500" u="none" strike="noStrike">
                 <a:solidFill>
@@ -32243,7 +32572,7 @@
         </p:sp>
         <p:sp>
           <p:nvSpPr>
-            <p:cNvPr id="628" name="Google Shape;628;p37"/>
+            <p:cNvPr id="632" name="Google Shape;632;p37"/>
             <p:cNvSpPr/>
             <p:nvPr/>
           </p:nvSpPr>
@@ -32294,7 +32623,7 @@
         </p:sp>
         <p:sp>
           <p:nvSpPr>
-            <p:cNvPr id="629" name="Google Shape;629;p37"/>
+            <p:cNvPr id="633" name="Google Shape;633;p37"/>
             <p:cNvSpPr txBox="1"/>
             <p:nvPr/>
           </p:nvSpPr>
@@ -32390,31 +32719,17 @@
               </a:endParaRPr>
             </a:p>
             <a:p>
-              <a:pPr indent="-323850" lvl="0" marL="457200" rtl="0" algn="l">
+              <a:pPr indent="0" lvl="0" marL="457200" rtl="0" algn="l">
                 <a:spcBef>
                   <a:spcPts val="600"/>
                 </a:spcBef>
                 <a:spcAft>
                   <a:spcPts val="0"/>
                 </a:spcAft>
-                <a:buClr>
-                  <a:srgbClr val="D32F2F"/>
-                </a:buClr>
-                <a:buSzPts val="1500"/>
-                <a:buFont typeface="Cambria"/>
-                <a:buChar char="●"/>
+                <a:buNone/>
               </a:pPr>
               <a:r>
-                <a:rPr b="0" i="0" lang="en-US" sz="1200" u="none" strike="noStrike">
-                  <a:solidFill>
-                    <a:srgbClr val="222222"/>
-                  </a:solidFill>
-                  <a:latin typeface="Cambria"/>
-                  <a:ea typeface="Cambria"/>
-                  <a:cs typeface="Cambria"/>
-                  <a:sym typeface="Cambria"/>
-                </a:rPr>
-                <a:t>Instability: thermal variance and seed impact the determination of results</a:t>
+                <a:t/>
               </a:r>
               <a:endParaRPr b="1" i="0" sz="1500" u="none" strike="noStrike">
                 <a:solidFill>
@@ -32431,7 +32746,7 @@
       </p:grpSp>
       <p:sp>
         <p:nvSpPr>
-          <p:cNvPr id="630" name="Google Shape;630;p37"/>
+          <p:cNvPr id="634" name="Google Shape;634;p37"/>
           <p:cNvSpPr/>
           <p:nvPr/>
         </p:nvSpPr>
@@ -32489,7 +32804,7 @@
       </p:sp>
       <p:grpSp>
         <p:nvGrpSpPr>
-          <p:cNvPr id="631" name="Google Shape;631;p37"/>
+          <p:cNvPr id="635" name="Google Shape;635;p37"/>
           <p:cNvGrpSpPr/>
           <p:nvPr/>
         </p:nvGrpSpPr>
@@ -32503,7 +32818,7 @@
         </p:grpSpPr>
         <p:pic>
           <p:nvPicPr>
-            <p:cNvPr id="632" name="Google Shape;632;p37"/>
+            <p:cNvPr id="636" name="Google Shape;636;p37"/>
             <p:cNvPicPr preferRelativeResize="0"/>
             <p:nvPr/>
           </p:nvPicPr>
@@ -32530,7 +32845,7 @@
         </p:pic>
         <p:sp>
           <p:nvSpPr>
-            <p:cNvPr id="633" name="Google Shape;633;p37"/>
+            <p:cNvPr id="637" name="Google Shape;637;p37"/>
             <p:cNvSpPr txBox="1"/>
             <p:nvPr/>
           </p:nvSpPr>
@@ -32625,7 +32940,7 @@
       </p:grpSp>
       <p:sp>
         <p:nvSpPr>
-          <p:cNvPr id="634" name="Google Shape;634;p37"/>
+          <p:cNvPr id="638" name="Google Shape;638;p37"/>
           <p:cNvSpPr txBox="1"/>
           <p:nvPr/>
         </p:nvSpPr>
@@ -32693,7 +33008,7 @@
     </p:bg>
     <p:spTree>
       <p:nvGrpSpPr>
-        <p:cNvPr id="638" name="Shape 638"/>
+        <p:cNvPr id="642" name="Shape 642"/>
         <p:cNvGrpSpPr/>
         <p:nvPr/>
       </p:nvGrpSpPr>
@@ -32707,7 +33022,7 @@
       </p:grpSpPr>
       <p:pic>
         <p:nvPicPr>
-          <p:cNvPr descr="polito_logo.png" id="639" name="Google Shape;639;p38"/>
+          <p:cNvPr descr="polito_logo.png" id="643" name="Google Shape;643;p38"/>
           <p:cNvPicPr preferRelativeResize="0"/>
           <p:nvPr/>
         </p:nvPicPr>
@@ -32734,7 +33049,7 @@
       </p:pic>
       <p:sp>
         <p:nvSpPr>
-          <p:cNvPr id="640" name="Google Shape;640;p38"/>
+          <p:cNvPr id="644" name="Google Shape;644;p38"/>
           <p:cNvSpPr txBox="1"/>
           <p:nvPr/>
         </p:nvSpPr>
@@ -32784,7 +33099,7 @@
       </p:sp>
       <p:sp>
         <p:nvSpPr>
-          <p:cNvPr id="641" name="Google Shape;641;p38"/>
+          <p:cNvPr id="645" name="Google Shape;645;p38"/>
           <p:cNvSpPr txBox="1"/>
           <p:nvPr/>
         </p:nvSpPr>
@@ -32834,7 +33149,7 @@
       </p:sp>
       <p:sp>
         <p:nvSpPr>
-          <p:cNvPr id="642" name="Google Shape;642;p38"/>
+          <p:cNvPr id="646" name="Google Shape;646;p38"/>
           <p:cNvSpPr txBox="1"/>
           <p:nvPr/>
         </p:nvSpPr>
@@ -32884,7 +33199,7 @@
       </p:sp>
       <p:sp>
         <p:nvSpPr>
-          <p:cNvPr id="643" name="Google Shape;643;p38"/>
+          <p:cNvPr id="647" name="Google Shape;647;p38"/>
           <p:cNvSpPr/>
           <p:nvPr/>
         </p:nvSpPr>
@@ -32942,7 +33257,7 @@
       </p:sp>
       <p:sp>
         <p:nvSpPr>
-          <p:cNvPr id="644" name="Google Shape;644;p38"/>
+          <p:cNvPr id="648" name="Google Shape;648;p38"/>
           <p:cNvSpPr/>
           <p:nvPr/>
         </p:nvSpPr>
@@ -33000,7 +33315,7 @@
       </p:sp>
       <p:sp>
         <p:nvSpPr>
-          <p:cNvPr id="645" name="Google Shape;645;p38"/>
+          <p:cNvPr id="649" name="Google Shape;649;p38"/>
           <p:cNvSpPr/>
           <p:nvPr/>
         </p:nvSpPr>
@@ -33058,7 +33373,7 @@
       </p:sp>
       <p:sp>
         <p:nvSpPr>
-          <p:cNvPr id="646" name="Google Shape;646;p38"/>
+          <p:cNvPr id="650" name="Google Shape;650;p38"/>
           <p:cNvSpPr txBox="1"/>
           <p:nvPr/>
         </p:nvSpPr>
@@ -33108,7 +33423,7 @@
       </p:sp>
       <p:grpSp>
         <p:nvGrpSpPr>
-          <p:cNvPr id="647" name="Google Shape;647;p38"/>
+          <p:cNvPr id="651" name="Google Shape;651;p38"/>
           <p:cNvGrpSpPr/>
           <p:nvPr/>
         </p:nvGrpSpPr>
@@ -33122,7 +33437,7 @@
         </p:grpSpPr>
         <p:sp>
           <p:nvSpPr>
-            <p:cNvPr id="648" name="Google Shape;648;p38"/>
+            <p:cNvPr id="652" name="Google Shape;652;p38"/>
             <p:cNvSpPr/>
             <p:nvPr/>
           </p:nvSpPr>
@@ -33169,7 +33484,7 @@
         </p:sp>
         <p:sp>
           <p:nvSpPr>
-            <p:cNvPr id="649" name="Google Shape;649;p38"/>
+            <p:cNvPr id="653" name="Google Shape;653;p38"/>
             <p:cNvSpPr txBox="1"/>
             <p:nvPr/>
           </p:nvSpPr>
@@ -33365,152 +33680,6 @@
                   <a:cs typeface="Cambria"/>
                   <a:sym typeface="Cambria"/>
                 </a:rPr>
-                <a:t>Conversational Filtering:</a:t>
-              </a:r>
-              <a:r>
-                <a:rPr lang="en-US" sz="900">
-                  <a:solidFill>
-                    <a:schemeClr val="dk1"/>
-                  </a:solidFill>
-                  <a:latin typeface="Cambria"/>
-                  <a:ea typeface="Cambria"/>
-                  <a:cs typeface="Cambria"/>
-                  <a:sym typeface="Cambria"/>
-                </a:rPr>
-                <a:t> Automatically detects and removes common LLM introductory phrases (e.g., "Here is the code:", "This script...") that would otherwise trigger syntax errors.</a:t>
-              </a:r>
-              <a:endParaRPr sz="900">
-                <a:solidFill>
-                  <a:schemeClr val="dk1"/>
-                </a:solidFill>
-                <a:latin typeface="Cambria"/>
-                <a:ea typeface="Cambria"/>
-                <a:cs typeface="Cambria"/>
-                <a:sym typeface="Cambria"/>
-              </a:endParaRPr>
-            </a:p>
-            <a:p>
-              <a:pPr indent="-285750" lvl="0" marL="457200" rtl="0" algn="l">
-                <a:spcBef>
-                  <a:spcPts val="450"/>
-                </a:spcBef>
-                <a:spcAft>
-                  <a:spcPts val="0"/>
-                </a:spcAft>
-                <a:buClr>
-                  <a:srgbClr val="222222"/>
-                </a:buClr>
-                <a:buSzPts val="900"/>
-                <a:buFont typeface="Cambria"/>
-                <a:buChar char="●"/>
-              </a:pPr>
-              <a:r>
-                <a:rPr b="1" lang="en-US" sz="900">
-                  <a:solidFill>
-                    <a:schemeClr val="dk1"/>
-                  </a:solidFill>
-                  <a:latin typeface="Cambria"/>
-                  <a:ea typeface="Cambria"/>
-                  <a:cs typeface="Cambria"/>
-                  <a:sym typeface="Cambria"/>
-                </a:rPr>
-                <a:t>Import Normalization:</a:t>
-              </a:r>
-              <a:r>
-                <a:rPr lang="en-US" sz="900">
-                  <a:solidFill>
-                    <a:schemeClr val="dk1"/>
-                  </a:solidFill>
-                  <a:latin typeface="Cambria"/>
-                  <a:ea typeface="Cambria"/>
-                  <a:cs typeface="Cambria"/>
-                  <a:sym typeface="Cambria"/>
-                </a:rPr>
-                <a:t> Specifically identifies and strips hallucinated placeholder modules like </a:t>
-              </a:r>
-              <a:r>
-                <a:rPr lang="en-US" sz="900">
-                  <a:solidFill>
-                    <a:srgbClr val="188038"/>
-                  </a:solidFill>
-                  <a:latin typeface="Cambria"/>
-                  <a:ea typeface="Cambria"/>
-                  <a:cs typeface="Cambria"/>
-                  <a:sym typeface="Cambria"/>
-                </a:rPr>
-                <a:t>your_module</a:t>
-              </a:r>
-              <a:r>
-                <a:rPr lang="en-US" sz="900">
-                  <a:solidFill>
-                    <a:schemeClr val="dk1"/>
-                  </a:solidFill>
-                  <a:latin typeface="Cambria"/>
-                  <a:ea typeface="Cambria"/>
-                  <a:cs typeface="Cambria"/>
-                  <a:sym typeface="Cambria"/>
-                </a:rPr>
-                <a:t> or </a:t>
-              </a:r>
-              <a:r>
-                <a:rPr lang="en-US" sz="900">
-                  <a:solidFill>
-                    <a:srgbClr val="188038"/>
-                  </a:solidFill>
-                  <a:latin typeface="Cambria"/>
-                  <a:ea typeface="Cambria"/>
-                  <a:cs typeface="Cambria"/>
-                  <a:sym typeface="Cambria"/>
-                </a:rPr>
-                <a:t>solution_module</a:t>
-              </a:r>
-              <a:r>
-                <a:rPr lang="en-US" sz="900">
-                  <a:solidFill>
-                    <a:schemeClr val="dk1"/>
-                  </a:solidFill>
-                  <a:latin typeface="Cambria"/>
-                  <a:ea typeface="Cambria"/>
-                  <a:cs typeface="Cambria"/>
-                  <a:sym typeface="Cambria"/>
-                </a:rPr>
-                <a:t> often generated during unit test creation.</a:t>
-              </a:r>
-              <a:endParaRPr sz="900">
-                <a:solidFill>
-                  <a:schemeClr val="dk1"/>
-                </a:solidFill>
-                <a:latin typeface="Cambria"/>
-                <a:ea typeface="Cambria"/>
-                <a:cs typeface="Cambria"/>
-                <a:sym typeface="Cambria"/>
-              </a:endParaRPr>
-            </a:p>
-            <a:p>
-              <a:pPr indent="-285750" lvl="0" marL="457200" rtl="0" algn="l">
-                <a:spcBef>
-                  <a:spcPts val="450"/>
-                </a:spcBef>
-                <a:spcAft>
-                  <a:spcPts val="0"/>
-                </a:spcAft>
-                <a:buClr>
-                  <a:srgbClr val="222222"/>
-                </a:buClr>
-                <a:buSzPts val="900"/>
-                <a:buFont typeface="Cambria"/>
-                <a:buChar char="●"/>
-              </a:pPr>
-              <a:r>
-                <a:rPr b="1" lang="en-US" sz="900">
-                  <a:solidFill>
-                    <a:schemeClr val="dk1"/>
-                  </a:solidFill>
-                  <a:latin typeface="Cambria"/>
-                  <a:ea typeface="Cambria"/>
-                  <a:cs typeface="Cambria"/>
-                  <a:sym typeface="Cambria"/>
-                </a:rPr>
                 <a:t>Robust Fallback logic:</a:t>
               </a:r>
               <a:r>
@@ -33562,7 +33731,7 @@
         </p:sp>
         <p:sp>
           <p:nvSpPr>
-            <p:cNvPr id="650" name="Google Shape;650;p38"/>
+            <p:cNvPr id="654" name="Google Shape;654;p38"/>
             <p:cNvSpPr/>
             <p:nvPr/>
           </p:nvSpPr>
@@ -33607,7 +33776,7 @@
         </p:sp>
         <p:sp>
           <p:nvSpPr>
-            <p:cNvPr id="651" name="Google Shape;651;p38"/>
+            <p:cNvPr id="655" name="Google Shape;655;p38"/>
             <p:cNvSpPr/>
             <p:nvPr/>
           </p:nvSpPr>
@@ -33652,7 +33821,7 @@
         </p:sp>
         <p:sp>
           <p:nvSpPr>
-            <p:cNvPr id="652" name="Google Shape;652;p38"/>
+            <p:cNvPr id="656" name="Google Shape;656;p38"/>
             <p:cNvSpPr/>
             <p:nvPr/>
           </p:nvSpPr>
@@ -33695,7 +33864,7 @@
         </p:sp>
         <p:sp>
           <p:nvSpPr>
-            <p:cNvPr id="653" name="Google Shape;653;p38"/>
+            <p:cNvPr id="657" name="Google Shape;657;p38"/>
             <p:cNvSpPr/>
             <p:nvPr/>
           </p:nvSpPr>
@@ -33738,7 +33907,7 @@
         </p:sp>
         <p:sp>
           <p:nvSpPr>
-            <p:cNvPr id="654" name="Google Shape;654;p38"/>
+            <p:cNvPr id="658" name="Google Shape;658;p38"/>
             <p:cNvSpPr/>
             <p:nvPr/>
           </p:nvSpPr>
@@ -33781,7 +33950,7 @@
         </p:sp>
         <p:sp>
           <p:nvSpPr>
-            <p:cNvPr id="655" name="Google Shape;655;p38"/>
+            <p:cNvPr id="659" name="Google Shape;659;p38"/>
             <p:cNvSpPr txBox="1"/>
             <p:nvPr/>
           </p:nvSpPr>
@@ -34692,7 +34861,7 @@
       </p:grpSp>
       <p:grpSp>
         <p:nvGrpSpPr>
-          <p:cNvPr id="656" name="Google Shape;656;p38"/>
+          <p:cNvPr id="660" name="Google Shape;660;p38"/>
           <p:cNvGrpSpPr/>
           <p:nvPr/>
         </p:nvGrpSpPr>
@@ -34706,7 +34875,7 @@
         </p:grpSpPr>
         <p:sp>
           <p:nvSpPr>
-            <p:cNvPr id="657" name="Google Shape;657;p38"/>
+            <p:cNvPr id="661" name="Google Shape;661;p38"/>
             <p:cNvSpPr/>
             <p:nvPr/>
           </p:nvSpPr>
@@ -34757,7 +34926,7 @@
         </p:sp>
         <p:sp>
           <p:nvSpPr>
-            <p:cNvPr id="658" name="Google Shape;658;p38"/>
+            <p:cNvPr id="662" name="Google Shape;662;p38"/>
             <p:cNvSpPr txBox="1"/>
             <p:nvPr/>
           </p:nvSpPr>
@@ -34815,7 +34984,7 @@
                   <a:cs typeface="Cambria"/>
                   <a:sym typeface="Cambria"/>
                 </a:rPr>
-                <a:t> By parsing the code first, we avoid executing malicious or broken scripts in our testing environment. </a:t>
+                <a:t> By parsing the code first, we avoid executing broken scripts in our testing environment. </a:t>
               </a:r>
               <a:endParaRPr b="0" sz="1300">
                 <a:solidFill>
@@ -34832,7 +35001,7 @@
       </p:grpSp>
       <p:sp>
         <p:nvSpPr>
-          <p:cNvPr id="659" name="Google Shape;659;p38"/>
+          <p:cNvPr id="663" name="Google Shape;663;p38"/>
           <p:cNvSpPr txBox="1"/>
           <p:nvPr/>
         </p:nvSpPr>
@@ -34912,7 +35081,7 @@
     </p:bg>
     <p:spTree>
       <p:nvGrpSpPr>
-        <p:cNvPr id="663" name="Shape 663"/>
+        <p:cNvPr id="667" name="Shape 667"/>
         <p:cNvGrpSpPr/>
         <p:nvPr/>
       </p:nvGrpSpPr>
@@ -34926,7 +35095,7 @@
       </p:grpSpPr>
       <p:pic>
         <p:nvPicPr>
-          <p:cNvPr descr="polito_logo.png" id="664" name="Google Shape;664;p39"/>
+          <p:cNvPr descr="polito_logo.png" id="668" name="Google Shape;668;p39"/>
           <p:cNvPicPr preferRelativeResize="0"/>
           <p:nvPr/>
         </p:nvPicPr>
@@ -34953,7 +35122,7 @@
       </p:pic>
       <p:sp>
         <p:nvSpPr>
-          <p:cNvPr id="665" name="Google Shape;665;p39"/>
+          <p:cNvPr id="669" name="Google Shape;669;p39"/>
           <p:cNvSpPr txBox="1"/>
           <p:nvPr/>
         </p:nvSpPr>
@@ -35003,7 +35172,7 @@
       </p:sp>
       <p:sp>
         <p:nvSpPr>
-          <p:cNvPr id="666" name="Google Shape;666;p39"/>
+          <p:cNvPr id="670" name="Google Shape;670;p39"/>
           <p:cNvSpPr txBox="1"/>
           <p:nvPr/>
         </p:nvSpPr>
@@ -35053,7 +35222,7 @@
       </p:sp>
       <p:sp>
         <p:nvSpPr>
-          <p:cNvPr id="667" name="Google Shape;667;p39"/>
+          <p:cNvPr id="671" name="Google Shape;671;p39"/>
           <p:cNvSpPr txBox="1"/>
           <p:nvPr/>
         </p:nvSpPr>
@@ -35103,7 +35272,7 @@
       </p:sp>
       <p:sp>
         <p:nvSpPr>
-          <p:cNvPr id="668" name="Google Shape;668;p39"/>
+          <p:cNvPr id="672" name="Google Shape;672;p39"/>
           <p:cNvSpPr txBox="1"/>
           <p:nvPr/>
         </p:nvSpPr>
@@ -35177,7 +35346,7 @@
       </p:sp>
       <p:sp>
         <p:nvSpPr>
-          <p:cNvPr id="669" name="Google Shape;669;p39"/>
+          <p:cNvPr id="673" name="Google Shape;673;p39"/>
           <p:cNvSpPr/>
           <p:nvPr/>
         </p:nvSpPr>
@@ -35235,7 +35404,7 @@
       </p:sp>
       <p:sp>
         <p:nvSpPr>
-          <p:cNvPr id="670" name="Google Shape;670;p39"/>
+          <p:cNvPr id="674" name="Google Shape;674;p39"/>
           <p:cNvSpPr/>
           <p:nvPr/>
         </p:nvSpPr>
@@ -35293,7 +35462,7 @@
       </p:sp>
       <p:sp>
         <p:nvSpPr>
-          <p:cNvPr id="671" name="Google Shape;671;p39"/>
+          <p:cNvPr id="675" name="Google Shape;675;p39"/>
           <p:cNvSpPr/>
           <p:nvPr/>
         </p:nvSpPr>
@@ -35351,7 +35520,7 @@
       </p:sp>
       <p:sp>
         <p:nvSpPr>
-          <p:cNvPr id="672" name="Google Shape;672;p39"/>
+          <p:cNvPr id="676" name="Google Shape;676;p39"/>
           <p:cNvSpPr txBox="1"/>
           <p:nvPr/>
         </p:nvSpPr>
@@ -35401,7 +35570,7 @@
       </p:sp>
       <p:grpSp>
         <p:nvGrpSpPr>
-          <p:cNvPr id="673" name="Google Shape;673;p39"/>
+          <p:cNvPr id="677" name="Google Shape;677;p39"/>
           <p:cNvGrpSpPr/>
           <p:nvPr/>
         </p:nvGrpSpPr>
@@ -35415,7 +35584,7 @@
         </p:grpSpPr>
         <p:sp>
           <p:nvSpPr>
-            <p:cNvPr id="674" name="Google Shape;674;p39"/>
+            <p:cNvPr id="678" name="Google Shape;678;p39"/>
             <p:cNvSpPr/>
             <p:nvPr/>
           </p:nvSpPr>
@@ -35462,7 +35631,7 @@
         </p:sp>
         <p:sp>
           <p:nvSpPr>
-            <p:cNvPr id="675" name="Google Shape;675;p39"/>
+            <p:cNvPr id="679" name="Google Shape;679;p39"/>
             <p:cNvSpPr txBox="1"/>
             <p:nvPr/>
           </p:nvSpPr>
@@ -35671,7 +35840,7 @@
         </p:sp>
         <p:sp>
           <p:nvSpPr>
-            <p:cNvPr id="676" name="Google Shape;676;p39"/>
+            <p:cNvPr id="680" name="Google Shape;680;p39"/>
             <p:cNvSpPr/>
             <p:nvPr/>
           </p:nvSpPr>
@@ -35718,7 +35887,7 @@
         </p:sp>
         <p:sp>
           <p:nvSpPr>
-            <p:cNvPr id="677" name="Google Shape;677;p39"/>
+            <p:cNvPr id="681" name="Google Shape;681;p39"/>
             <p:cNvSpPr txBox="1"/>
             <p:nvPr/>
           </p:nvSpPr>
@@ -35928,7 +36097,7 @@
       </p:grpSp>
       <p:grpSp>
         <p:nvGrpSpPr>
-          <p:cNvPr id="678" name="Google Shape;678;p39"/>
+          <p:cNvPr id="682" name="Google Shape;682;p39"/>
           <p:cNvGrpSpPr/>
           <p:nvPr/>
         </p:nvGrpSpPr>
@@ -35942,7 +36111,7 @@
         </p:grpSpPr>
         <p:sp>
           <p:nvSpPr>
-            <p:cNvPr id="679" name="Google Shape;679;p39"/>
+            <p:cNvPr id="683" name="Google Shape;683;p39"/>
             <p:cNvSpPr/>
             <p:nvPr/>
           </p:nvSpPr>
@@ -35995,7 +36164,7 @@
         </p:sp>
         <p:sp>
           <p:nvSpPr>
-            <p:cNvPr id="680" name="Google Shape;680;p39"/>
+            <p:cNvPr id="684" name="Google Shape;684;p39"/>
             <p:cNvSpPr txBox="1"/>
             <p:nvPr/>
           </p:nvSpPr>
@@ -36076,7 +36245,7 @@
     </p:bg>
     <p:spTree>
       <p:nvGrpSpPr>
-        <p:cNvPr id="684" name="Shape 684"/>
+        <p:cNvPr id="688" name="Shape 688"/>
         <p:cNvGrpSpPr/>
         <p:nvPr/>
       </p:nvGrpSpPr>
@@ -36090,7 +36259,7 @@
       </p:grpSpPr>
       <p:pic>
         <p:nvPicPr>
-          <p:cNvPr descr="polito_logo.png" id="685" name="Google Shape;685;p40"/>
+          <p:cNvPr descr="polito_logo.png" id="689" name="Google Shape;689;p40"/>
           <p:cNvPicPr preferRelativeResize="0"/>
           <p:nvPr/>
         </p:nvPicPr>
@@ -36117,7 +36286,7 @@
       </p:pic>
       <p:sp>
         <p:nvSpPr>
-          <p:cNvPr id="686" name="Google Shape;686;p40"/>
+          <p:cNvPr id="690" name="Google Shape;690;p40"/>
           <p:cNvSpPr txBox="1"/>
           <p:nvPr/>
         </p:nvSpPr>
@@ -36167,7 +36336,7 @@
       </p:sp>
       <p:sp>
         <p:nvSpPr>
-          <p:cNvPr id="687" name="Google Shape;687;p40"/>
+          <p:cNvPr id="691" name="Google Shape;691;p40"/>
           <p:cNvSpPr txBox="1"/>
           <p:nvPr/>
         </p:nvSpPr>
@@ -36217,7 +36386,7 @@
       </p:sp>
       <p:sp>
         <p:nvSpPr>
-          <p:cNvPr id="688" name="Google Shape;688;p40"/>
+          <p:cNvPr id="692" name="Google Shape;692;p40"/>
           <p:cNvSpPr txBox="1"/>
           <p:nvPr/>
         </p:nvSpPr>
@@ -36267,7 +36436,7 @@
       </p:sp>
       <p:sp>
         <p:nvSpPr>
-          <p:cNvPr id="689" name="Google Shape;689;p40"/>
+          <p:cNvPr id="693" name="Google Shape;693;p40"/>
           <p:cNvSpPr txBox="1"/>
           <p:nvPr/>
         </p:nvSpPr>
@@ -36341,7 +36510,7 @@
       </p:sp>
       <p:sp>
         <p:nvSpPr>
-          <p:cNvPr id="690" name="Google Shape;690;p40"/>
+          <p:cNvPr id="694" name="Google Shape;694;p40"/>
           <p:cNvSpPr/>
           <p:nvPr/>
         </p:nvSpPr>
@@ -36399,7 +36568,7 @@
       </p:sp>
       <p:sp>
         <p:nvSpPr>
-          <p:cNvPr id="691" name="Google Shape;691;p40"/>
+          <p:cNvPr id="695" name="Google Shape;695;p40"/>
           <p:cNvSpPr/>
           <p:nvPr/>
         </p:nvSpPr>
@@ -36457,7 +36626,7 @@
       </p:sp>
       <p:grpSp>
         <p:nvGrpSpPr>
-          <p:cNvPr id="692" name="Google Shape;692;p40"/>
+          <p:cNvPr id="696" name="Google Shape;696;p40"/>
           <p:cNvGrpSpPr/>
           <p:nvPr/>
         </p:nvGrpSpPr>
@@ -36471,7 +36640,7 @@
         </p:grpSpPr>
         <p:sp>
           <p:nvSpPr>
-            <p:cNvPr id="693" name="Google Shape;693;p40"/>
+            <p:cNvPr id="697" name="Google Shape;697;p40"/>
             <p:cNvSpPr/>
             <p:nvPr/>
           </p:nvSpPr>
@@ -36518,7 +36687,7 @@
         </p:sp>
         <p:sp>
           <p:nvSpPr>
-            <p:cNvPr id="694" name="Google Shape;694;p40"/>
+            <p:cNvPr id="698" name="Google Shape;698;p40"/>
             <p:cNvSpPr txBox="1"/>
             <p:nvPr/>
           </p:nvSpPr>
@@ -36640,7 +36809,7 @@
         </p:sp>
         <p:sp>
           <p:nvSpPr>
-            <p:cNvPr id="695" name="Google Shape;695;p40"/>
+            <p:cNvPr id="699" name="Google Shape;699;p40"/>
             <p:cNvSpPr/>
             <p:nvPr/>
           </p:nvSpPr>
@@ -36687,7 +36856,7 @@
         </p:sp>
         <p:sp>
           <p:nvSpPr>
-            <p:cNvPr id="696" name="Google Shape;696;p40"/>
+            <p:cNvPr id="700" name="Google Shape;700;p40"/>
             <p:cNvSpPr txBox="1"/>
             <p:nvPr/>
           </p:nvSpPr>
@@ -36809,7 +36978,7 @@
         </p:sp>
         <p:sp>
           <p:nvSpPr>
-            <p:cNvPr id="697" name="Google Shape;697;p40"/>
+            <p:cNvPr id="701" name="Google Shape;701;p40"/>
             <p:cNvSpPr/>
             <p:nvPr/>
           </p:nvSpPr>
@@ -36862,7 +37031,7 @@
         </p:sp>
         <p:sp>
           <p:nvSpPr>
-            <p:cNvPr id="698" name="Google Shape;698;p40"/>
+            <p:cNvPr id="702" name="Google Shape;702;p40"/>
             <p:cNvSpPr txBox="1"/>
             <p:nvPr/>
           </p:nvSpPr>
@@ -36985,7 +37154,7 @@
       </p:grpSp>
       <p:grpSp>
         <p:nvGrpSpPr>
-          <p:cNvPr id="699" name="Google Shape;699;p40"/>
+          <p:cNvPr id="703" name="Google Shape;703;p40"/>
           <p:cNvGrpSpPr/>
           <p:nvPr/>
         </p:nvGrpSpPr>
@@ -36999,7 +37168,7 @@
         </p:grpSpPr>
         <p:sp>
           <p:nvSpPr>
-            <p:cNvPr id="700" name="Google Shape;700;p40"/>
+            <p:cNvPr id="704" name="Google Shape;704;p40"/>
             <p:cNvSpPr/>
             <p:nvPr/>
           </p:nvSpPr>
@@ -37050,7 +37219,7 @@
         </p:sp>
         <p:sp>
           <p:nvSpPr>
-            <p:cNvPr id="701" name="Google Shape;701;p40"/>
+            <p:cNvPr id="705" name="Google Shape;705;p40"/>
             <p:cNvSpPr txBox="1"/>
             <p:nvPr/>
           </p:nvSpPr>
@@ -37141,7 +37310,7 @@
       </p:grpSp>
       <p:sp>
         <p:nvSpPr>
-          <p:cNvPr id="702" name="Google Shape;702;p40"/>
+          <p:cNvPr id="706" name="Google Shape;706;p40"/>
           <p:cNvSpPr/>
           <p:nvPr/>
         </p:nvSpPr>
@@ -37199,7 +37368,7 @@
       </p:sp>
       <p:sp>
         <p:nvSpPr>
-          <p:cNvPr id="703" name="Google Shape;703;p40"/>
+          <p:cNvPr id="707" name="Google Shape;707;p40"/>
           <p:cNvSpPr txBox="1"/>
           <p:nvPr/>
         </p:nvSpPr>
@@ -37272,7 +37441,7 @@
     </p:bg>
     <p:spTree>
       <p:nvGrpSpPr>
-        <p:cNvPr id="707" name="Shape 707"/>
+        <p:cNvPr id="711" name="Shape 711"/>
         <p:cNvGrpSpPr/>
         <p:nvPr/>
       </p:nvGrpSpPr>
@@ -37286,7 +37455,7 @@
       </p:grpSpPr>
       <p:pic>
         <p:nvPicPr>
-          <p:cNvPr descr="polito_logo.png" id="708" name="Google Shape;708;p41"/>
+          <p:cNvPr descr="polito_logo.png" id="712" name="Google Shape;712;p41"/>
           <p:cNvPicPr preferRelativeResize="0"/>
           <p:nvPr/>
         </p:nvPicPr>
@@ -37313,7 +37482,7 @@
       </p:pic>
       <p:sp>
         <p:nvSpPr>
-          <p:cNvPr id="709" name="Google Shape;709;p41"/>
+          <p:cNvPr id="713" name="Google Shape;713;p41"/>
           <p:cNvSpPr txBox="1"/>
           <p:nvPr/>
         </p:nvSpPr>
@@ -37375,7 +37544,7 @@
       </p:sp>
       <p:sp>
         <p:nvSpPr>
-          <p:cNvPr id="710" name="Google Shape;710;p41"/>
+          <p:cNvPr id="714" name="Google Shape;714;p41"/>
           <p:cNvSpPr txBox="1"/>
           <p:nvPr/>
         </p:nvSpPr>
@@ -37425,7 +37594,7 @@
       </p:sp>
       <p:sp>
         <p:nvSpPr>
-          <p:cNvPr id="711" name="Google Shape;711;p41"/>
+          <p:cNvPr id="715" name="Google Shape;715;p41"/>
           <p:cNvSpPr/>
           <p:nvPr/>
         </p:nvSpPr>
@@ -37483,7 +37652,7 @@
       </p:sp>
       <p:sp>
         <p:nvSpPr>
-          <p:cNvPr id="712" name="Google Shape;712;p41"/>
+          <p:cNvPr id="716" name="Google Shape;716;p41"/>
           <p:cNvSpPr txBox="1"/>
           <p:nvPr/>
         </p:nvSpPr>
@@ -37545,7 +37714,7 @@
       </p:sp>
       <p:sp>
         <p:nvSpPr>
-          <p:cNvPr id="713" name="Google Shape;713;p41"/>
+          <p:cNvPr id="717" name="Google Shape;717;p41"/>
           <p:cNvSpPr/>
           <p:nvPr/>
         </p:nvSpPr>
@@ -38537,7 +38706,31 @@
                   <a:cs typeface="Cambria"/>
                   <a:sym typeface="Cambria"/>
                 </a:rPr>
-                <a:t>Vanilla HumanEval only has ~7 simple tests. LLMs often "memorize" these standard solutions. EvalPlus is an evolution of HumanEval.</a:t>
+                <a:t>Vanilla HumanEval only has ~7 simple tests. LLMs often "memorize" these standard solutions. EvalPlus is an evolution of HumanEval with </a:t>
+              </a:r>
+              <a:r>
+                <a:rPr lang="en-US" sz="1050">
+                  <a:solidFill>
+                    <a:srgbClr val="64748B"/>
+                  </a:solidFill>
+                  <a:latin typeface="Cambria"/>
+                  <a:ea typeface="Cambria"/>
+                  <a:cs typeface="Cambria"/>
+                  <a:sym typeface="Cambria"/>
+                </a:rPr>
+                <a:t>up to 700+ tests per task </a:t>
+              </a:r>
+              <a:r>
+                <a:rPr b="0" i="0" lang="en-US" sz="1050">
+                  <a:solidFill>
+                    <a:srgbClr val="64748B"/>
+                  </a:solidFill>
+                  <a:latin typeface="Cambria"/>
+                  <a:ea typeface="Cambria"/>
+                  <a:cs typeface="Cambria"/>
+                  <a:sym typeface="Cambria"/>
+                </a:rPr>
+                <a:t>.</a:t>
               </a:r>
               <a:endParaRPr b="0" i="0" sz="1050">
                 <a:solidFill>
@@ -40212,7 +40405,7 @@
                   <a:cs typeface="Cambria"/>
                   <a:sym typeface="Cambria"/>
                 </a:rPr>
-                <a:t> CoT provides significant boost</a:t>
+                <a:t> SCoT provides significant boost</a:t>
               </a:r>
               <a:endParaRPr sz="1100">
                 <a:solidFill>
@@ -40611,7 +40804,76 @@
                   <a:cs typeface="Cambria"/>
                   <a:sym typeface="Cambria"/>
                 </a:rPr>
-                <a:t> 0.2 (Deterministic) vs 0.7 (Swarm diversity)</a:t>
+                <a:t> Deterministic vs  Probabilistic/”Creative”</a:t>
+              </a:r>
+              <a:endParaRPr sz="1100">
+                <a:solidFill>
+                  <a:srgbClr val="222222"/>
+                </a:solidFill>
+                <a:latin typeface="Cambria"/>
+                <a:ea typeface="Cambria"/>
+                <a:cs typeface="Cambria"/>
+                <a:sym typeface="Cambria"/>
+              </a:endParaRPr>
+            </a:p>
+            <a:p>
+              <a:pPr indent="0" lvl="0" marL="0" rtl="0" algn="l">
+                <a:spcBef>
+                  <a:spcPts val="1000"/>
+                </a:spcBef>
+                <a:spcAft>
+                  <a:spcPts val="0"/>
+                </a:spcAft>
+                <a:buNone/>
+              </a:pPr>
+              <a:r>
+                <a:rPr b="1" lang="en-US" sz="1100">
+                  <a:solidFill>
+                    <a:srgbClr val="002B5C"/>
+                  </a:solidFill>
+                  <a:latin typeface="Cambria"/>
+                  <a:ea typeface="Cambria"/>
+                  <a:cs typeface="Cambria"/>
+                  <a:sym typeface="Cambria"/>
+                </a:rPr>
+                <a:t>Experimental Control</a:t>
+              </a:r>
+              <a:endParaRPr b="1" sz="1100">
+                <a:solidFill>
+                  <a:srgbClr val="002B5C"/>
+                </a:solidFill>
+                <a:latin typeface="Cambria"/>
+                <a:ea typeface="Cambria"/>
+                <a:cs typeface="Cambria"/>
+                <a:sym typeface="Cambria"/>
+              </a:endParaRPr>
+            </a:p>
+            <a:p>
+              <a:pPr indent="-298450" lvl="0" marL="457200" rtl="0" algn="l">
+                <a:spcBef>
+                  <a:spcPts val="800"/>
+                </a:spcBef>
+                <a:spcAft>
+                  <a:spcPts val="0"/>
+                </a:spcAft>
+                <a:buClr>
+                  <a:srgbClr val="222222"/>
+                </a:buClr>
+                <a:buSzPts val="1100"/>
+                <a:buFont typeface="Cambria"/>
+                <a:buChar char="●"/>
+              </a:pPr>
+              <a:r>
+                <a:rPr lang="en-US" sz="1100">
+                  <a:solidFill>
+                    <a:srgbClr val="222222"/>
+                  </a:solidFill>
+                  <a:latin typeface="Cambria"/>
+                  <a:ea typeface="Cambria"/>
+                  <a:cs typeface="Cambria"/>
+                  <a:sym typeface="Cambria"/>
+                </a:rPr>
+                <a:t>Standardized system prompt for multi-agent fairness</a:t>
               </a:r>
               <a:endParaRPr sz="1100">
                 <a:solidFill>
@@ -40648,7 +40910,7 @@
                   <a:cs typeface="Cambria"/>
                   <a:sym typeface="Cambria"/>
                 </a:rPr>
-                <a:t>Tokens:</a:t>
+                <a:t>Ablation:</a:t>
               </a:r>
               <a:r>
                 <a:rPr lang="en-US" sz="1100">
@@ -40660,125 +40922,7 @@
                   <a:cs typeface="Cambria"/>
                   <a:sym typeface="Cambria"/>
                 </a:rPr>
-                <a:t> 1024 max (Sufficient for HumanEval)</a:t>
-              </a:r>
-              <a:endParaRPr sz="1100">
-                <a:solidFill>
-                  <a:srgbClr val="222222"/>
-                </a:solidFill>
-                <a:latin typeface="Cambria"/>
-                <a:ea typeface="Cambria"/>
-                <a:cs typeface="Cambria"/>
-                <a:sym typeface="Cambria"/>
-              </a:endParaRPr>
-            </a:p>
-            <a:p>
-              <a:pPr indent="0" lvl="0" marL="0" rtl="0" algn="l">
-                <a:spcBef>
-                  <a:spcPts val="1000"/>
-                </a:spcBef>
-                <a:spcAft>
-                  <a:spcPts val="0"/>
-                </a:spcAft>
-                <a:buNone/>
-              </a:pPr>
-              <a:r>
-                <a:rPr b="1" lang="en-US" sz="1100">
-                  <a:solidFill>
-                    <a:srgbClr val="002B5C"/>
-                  </a:solidFill>
-                  <a:latin typeface="Cambria"/>
-                  <a:ea typeface="Cambria"/>
-                  <a:cs typeface="Cambria"/>
-                  <a:sym typeface="Cambria"/>
-                </a:rPr>
-                <a:t>Experimental Control</a:t>
-              </a:r>
-              <a:endParaRPr b="1" sz="1100">
-                <a:solidFill>
-                  <a:srgbClr val="002B5C"/>
-                </a:solidFill>
-                <a:latin typeface="Cambria"/>
-                <a:ea typeface="Cambria"/>
-                <a:cs typeface="Cambria"/>
-                <a:sym typeface="Cambria"/>
-              </a:endParaRPr>
-            </a:p>
-            <a:p>
-              <a:pPr indent="-298450" lvl="0" marL="457200" rtl="0" algn="l">
-                <a:spcBef>
-                  <a:spcPts val="800"/>
-                </a:spcBef>
-                <a:spcAft>
-                  <a:spcPts val="0"/>
-                </a:spcAft>
-                <a:buClr>
-                  <a:srgbClr val="222222"/>
-                </a:buClr>
-                <a:buSzPts val="1100"/>
-                <a:buFont typeface="Cambria"/>
-                <a:buChar char="●"/>
-              </a:pPr>
-              <a:r>
-                <a:rPr lang="en-US" sz="1100">
-                  <a:solidFill>
-                    <a:srgbClr val="222222"/>
-                  </a:solidFill>
-                  <a:latin typeface="Cambria"/>
-                  <a:ea typeface="Cambria"/>
-                  <a:cs typeface="Cambria"/>
-                  <a:sym typeface="Cambria"/>
-                </a:rPr>
-                <a:t>Standardized system prompt for multi-agent fairness</a:t>
-              </a:r>
-              <a:endParaRPr sz="1100">
-                <a:solidFill>
-                  <a:srgbClr val="222222"/>
-                </a:solidFill>
-                <a:latin typeface="Cambria"/>
-                <a:ea typeface="Cambria"/>
-                <a:cs typeface="Cambria"/>
-                <a:sym typeface="Cambria"/>
-              </a:endParaRPr>
-            </a:p>
-            <a:p>
-              <a:pPr indent="-298450" lvl="0" marL="457200" rtl="0" algn="l">
-                <a:spcBef>
-                  <a:spcPts val="600"/>
-                </a:spcBef>
-                <a:spcAft>
-                  <a:spcPts val="0"/>
-                </a:spcAft>
-                <a:buClr>
-                  <a:srgbClr val="222222"/>
-                </a:buClr>
-                <a:buSzPts val="1100"/>
-                <a:buFont typeface="Cambria"/>
-                <a:buChar char="●"/>
-              </a:pPr>
-              <a:r>
-                <a:rPr b="1" lang="en-US" sz="1100">
-                  <a:solidFill>
-                    <a:srgbClr val="222222"/>
-                  </a:solidFill>
-                  <a:latin typeface="Cambria"/>
-                  <a:ea typeface="Cambria"/>
-                  <a:cs typeface="Cambria"/>
-                  <a:sym typeface="Cambria"/>
-                </a:rPr>
-                <a:t>Ablation:</a:t>
-              </a:r>
-              <a:r>
-                <a:rPr lang="en-US" sz="1100">
-                  <a:solidFill>
-                    <a:srgbClr val="222222"/>
-                  </a:solidFill>
-                  <a:latin typeface="Cambria"/>
-                  <a:ea typeface="Cambria"/>
-                  <a:cs typeface="Cambria"/>
-                  <a:sym typeface="Cambria"/>
-                </a:rPr>
-                <a:t> Prompt change alone → 0.30 PR delta</a:t>
+                <a:t> Prompt change alone → +6% PR delta</a:t>
               </a:r>
               <a:endParaRPr sz="1100">
                 <a:solidFill>

</xml_diff>